<commit_message>
updating figs with new go
</commit_message>
<xml_diff>
--- a/results/figures/site_maps.pptx
+++ b/results/figures/site_maps.pptx
@@ -54738,7 +54738,7 @@
           </p:nvSpPr>
           <p:spPr>
             <a:xfrm>
-              <a:off x="5695389" y="3195750"/>
+              <a:off x="5697081" y="3188187"/>
               <a:ext cx="144506" cy="144506"/>
             </a:xfrm>
             <a:prstGeom prst="ellipse">
@@ -54773,7 +54773,7 @@
           </p:nvSpPr>
           <p:spPr>
             <a:xfrm>
-              <a:off x="5697081" y="3188187"/>
+              <a:off x="4578135" y="4746265"/>
               <a:ext cx="144506" cy="144506"/>
             </a:xfrm>
             <a:prstGeom prst="ellipse">
@@ -54808,7 +54808,7 @@
           </p:nvSpPr>
           <p:spPr>
             <a:xfrm>
-              <a:off x="4578135" y="4746265"/>
+              <a:off x="3807967" y="4755688"/>
               <a:ext cx="144506" cy="144506"/>
             </a:xfrm>
             <a:prstGeom prst="ellipse">
@@ -54843,7 +54843,7 @@
           </p:nvSpPr>
           <p:spPr>
             <a:xfrm>
-              <a:off x="3807967" y="4755688"/>
+              <a:off x="5764374" y="3021048"/>
               <a:ext cx="144506" cy="144506"/>
             </a:xfrm>
             <a:prstGeom prst="ellipse">
@@ -54878,7 +54878,7 @@
           </p:nvSpPr>
           <p:spPr>
             <a:xfrm>
-              <a:off x="5764374" y="3021048"/>
+              <a:off x="5308174" y="3536459"/>
               <a:ext cx="144506" cy="144506"/>
             </a:xfrm>
             <a:prstGeom prst="ellipse">
@@ -54913,7 +54913,7 @@
           </p:nvSpPr>
           <p:spPr>
             <a:xfrm>
-              <a:off x="5308174" y="3536459"/>
+              <a:off x="5240587" y="3485855"/>
               <a:ext cx="144506" cy="144506"/>
             </a:xfrm>
             <a:prstGeom prst="ellipse">
@@ -54948,7 +54948,7 @@
           </p:nvSpPr>
           <p:spPr>
             <a:xfrm>
-              <a:off x="5240587" y="3485855"/>
+              <a:off x="6315652" y="2872406"/>
               <a:ext cx="144506" cy="144506"/>
             </a:xfrm>
             <a:prstGeom prst="ellipse">
@@ -54983,7 +54983,7 @@
           </p:nvSpPr>
           <p:spPr>
             <a:xfrm>
-              <a:off x="6315652" y="2872406"/>
+              <a:off x="3181293" y="4838053"/>
               <a:ext cx="144506" cy="144506"/>
             </a:xfrm>
             <a:prstGeom prst="ellipse">
@@ -55018,7 +55018,7 @@
           </p:nvSpPr>
           <p:spPr>
             <a:xfrm>
-              <a:off x="6316748" y="2870308"/>
+              <a:off x="5123546" y="3818085"/>
               <a:ext cx="144506" cy="144506"/>
             </a:xfrm>
             <a:prstGeom prst="ellipse">
@@ -55053,7 +55053,7 @@
           </p:nvSpPr>
           <p:spPr>
             <a:xfrm>
-              <a:off x="3181293" y="4838053"/>
+              <a:off x="5115404" y="3806165"/>
               <a:ext cx="144506" cy="144506"/>
             </a:xfrm>
             <a:prstGeom prst="ellipse">
@@ -55088,7 +55088,7 @@
           </p:nvSpPr>
           <p:spPr>
             <a:xfrm>
-              <a:off x="5123546" y="3818085"/>
+              <a:off x="5236913" y="3996038"/>
               <a:ext cx="144506" cy="144506"/>
             </a:xfrm>
             <a:prstGeom prst="ellipse">
@@ -55123,7 +55123,7 @@
           </p:nvSpPr>
           <p:spPr>
             <a:xfrm>
-              <a:off x="5115404" y="3806165"/>
+              <a:off x="5077225" y="3639682"/>
               <a:ext cx="144506" cy="144506"/>
             </a:xfrm>
             <a:prstGeom prst="ellipse">
@@ -55158,7 +55158,7 @@
           </p:nvSpPr>
           <p:spPr>
             <a:xfrm>
-              <a:off x="5236913" y="3996038"/>
+              <a:off x="5910367" y="2842694"/>
               <a:ext cx="144506" cy="144506"/>
             </a:xfrm>
             <a:prstGeom prst="ellipse">
@@ -55193,7 +55193,7 @@
           </p:nvSpPr>
           <p:spPr>
             <a:xfrm>
-              <a:off x="6653971" y="2545426"/>
+              <a:off x="5867473" y="2869761"/>
               <a:ext cx="144506" cy="144506"/>
             </a:xfrm>
             <a:prstGeom prst="ellipse">
@@ -55228,7 +55228,7 @@
           </p:nvSpPr>
           <p:spPr>
             <a:xfrm>
-              <a:off x="5077225" y="3639682"/>
+              <a:off x="4977967" y="4227762"/>
               <a:ext cx="144506" cy="144506"/>
             </a:xfrm>
             <a:prstGeom prst="ellipse">
@@ -55263,7 +55263,7 @@
           </p:nvSpPr>
           <p:spPr>
             <a:xfrm>
-              <a:off x="5910367" y="2842694"/>
+              <a:off x="4969215" y="4253201"/>
               <a:ext cx="144506" cy="144506"/>
             </a:xfrm>
             <a:prstGeom prst="ellipse">
@@ -55298,7 +55298,7 @@
           </p:nvSpPr>
           <p:spPr>
             <a:xfrm>
-              <a:off x="5867473" y="2869761"/>
+              <a:off x="5495878" y="3245996"/>
               <a:ext cx="144506" cy="144506"/>
             </a:xfrm>
             <a:prstGeom prst="ellipse">
@@ -55333,7 +55333,7 @@
           </p:nvSpPr>
           <p:spPr>
             <a:xfrm>
-              <a:off x="4977967" y="4227762"/>
+              <a:off x="4154622" y="4851490"/>
               <a:ext cx="144506" cy="144506"/>
             </a:xfrm>
             <a:prstGeom prst="ellipse">
@@ -55368,7 +55368,7 @@
           </p:nvSpPr>
           <p:spPr>
             <a:xfrm>
-              <a:off x="4969215" y="4253201"/>
+              <a:off x="4202904" y="4850569"/>
               <a:ext cx="144506" cy="144506"/>
             </a:xfrm>
             <a:prstGeom prst="ellipse">
@@ -55397,147 +55397,7 @@
         </p:sp>
         <p:sp>
           <p:nvSpPr>
-            <p:cNvPr id="1531" name="pt1531"/>
-            <p:cNvSpPr/>
-            <p:nvPr/>
-          </p:nvSpPr>
-          <p:spPr>
-            <a:xfrm>
-              <a:off x="5495878" y="3245996"/>
-              <a:ext cx="144506" cy="144506"/>
-            </a:xfrm>
-            <a:prstGeom prst="ellipse">
-              <a:avLst/>
-            </a:prstGeom>
-            <a:solidFill>
-              <a:srgbClr val="3155A9">
-                <a:alpha val="100000"/>
-              </a:srgbClr>
-            </a:solidFill>
-            <a:ln w="9000" cap="rnd">
-              <a:solidFill>
-                <a:srgbClr val="000000">
-                  <a:alpha val="100000"/>
-                </a:srgbClr>
-              </a:solidFill>
-              <a:prstDash val="solid"/>
-              <a:round/>
-            </a:ln>
-          </p:spPr>
-          <p:txBody>
-            <a:bodyPr/>
-            <a:lstStyle/>
-            <a:p/>
-          </p:txBody>
-        </p:sp>
-        <p:sp>
-          <p:nvSpPr>
-            <p:cNvPr id="1532" name="pt1532"/>
-            <p:cNvSpPr/>
-            <p:nvPr/>
-          </p:nvSpPr>
-          <p:spPr>
-            <a:xfrm>
-              <a:off x="4154622" y="4851490"/>
-              <a:ext cx="144506" cy="144506"/>
-            </a:xfrm>
-            <a:prstGeom prst="ellipse">
-              <a:avLst/>
-            </a:prstGeom>
-            <a:solidFill>
-              <a:srgbClr val="3155A9">
-                <a:alpha val="100000"/>
-              </a:srgbClr>
-            </a:solidFill>
-            <a:ln w="9000" cap="rnd">
-              <a:solidFill>
-                <a:srgbClr val="000000">
-                  <a:alpha val="100000"/>
-                </a:srgbClr>
-              </a:solidFill>
-              <a:prstDash val="solid"/>
-              <a:round/>
-            </a:ln>
-          </p:spPr>
-          <p:txBody>
-            <a:bodyPr/>
-            <a:lstStyle/>
-            <a:p/>
-          </p:txBody>
-        </p:sp>
-        <p:sp>
-          <p:nvSpPr>
-            <p:cNvPr id="1533" name="pt1533"/>
-            <p:cNvSpPr/>
-            <p:nvPr/>
-          </p:nvSpPr>
-          <p:spPr>
-            <a:xfrm>
-              <a:off x="4202904" y="4850569"/>
-              <a:ext cx="144506" cy="144506"/>
-            </a:xfrm>
-            <a:prstGeom prst="ellipse">
-              <a:avLst/>
-            </a:prstGeom>
-            <a:solidFill>
-              <a:srgbClr val="3155A9">
-                <a:alpha val="100000"/>
-              </a:srgbClr>
-            </a:solidFill>
-            <a:ln w="9000" cap="rnd">
-              <a:solidFill>
-                <a:srgbClr val="000000">
-                  <a:alpha val="100000"/>
-                </a:srgbClr>
-              </a:solidFill>
-              <a:prstDash val="solid"/>
-              <a:round/>
-            </a:ln>
-          </p:spPr>
-          <p:txBody>
-            <a:bodyPr/>
-            <a:lstStyle/>
-            <a:p/>
-          </p:txBody>
-        </p:sp>
-        <p:sp>
-          <p:nvSpPr>
-            <p:cNvPr id="1534" name="pt1534"/>
-            <p:cNvSpPr/>
-            <p:nvPr/>
-          </p:nvSpPr>
-          <p:spPr>
-            <a:xfrm>
-              <a:off x="5568579" y="3228402"/>
-              <a:ext cx="144506" cy="144506"/>
-            </a:xfrm>
-            <a:prstGeom prst="ellipse">
-              <a:avLst/>
-            </a:prstGeom>
-            <a:solidFill>
-              <a:srgbClr val="3155A9">
-                <a:alpha val="100000"/>
-              </a:srgbClr>
-            </a:solidFill>
-            <a:ln w="9000" cap="rnd">
-              <a:solidFill>
-                <a:srgbClr val="000000">
-                  <a:alpha val="100000"/>
-                </a:srgbClr>
-              </a:solidFill>
-              <a:prstDash val="solid"/>
-              <a:round/>
-            </a:ln>
-          </p:spPr>
-          <p:txBody>
-            <a:bodyPr/>
-            <a:lstStyle/>
-            <a:p/>
-          </p:txBody>
-        </p:sp>
-        <p:sp>
-          <p:nvSpPr>
-            <p:cNvPr id="1535" name="rc1535"/>
+            <p:cNvPr id="1531" name="rc1531"/>
             <p:cNvSpPr/>
             <p:nvPr/>
           </p:nvSpPr>
@@ -55572,7 +55432,7 @@
         </p:sp>
         <p:sp>
           <p:nvSpPr>
-            <p:cNvPr id="1536" name="rc1536"/>
+            <p:cNvPr id="1532" name="rc1532"/>
             <p:cNvSpPr/>
             <p:nvPr/>
           </p:nvSpPr>
@@ -55607,7 +55467,7 @@
         </p:sp>
         <p:sp>
           <p:nvSpPr>
-            <p:cNvPr id="1537" name="rc1537"/>
+            <p:cNvPr id="1533" name="rc1533"/>
             <p:cNvSpPr/>
             <p:nvPr/>
           </p:nvSpPr>
@@ -55642,7 +55502,7 @@
         </p:sp>
         <p:sp>
           <p:nvSpPr>
-            <p:cNvPr id="1538" name="rc1538"/>
+            <p:cNvPr id="1534" name="rc1534"/>
             <p:cNvSpPr/>
             <p:nvPr/>
           </p:nvSpPr>
@@ -55677,7 +55537,7 @@
         </p:sp>
         <p:sp>
           <p:nvSpPr>
-            <p:cNvPr id="1539" name="rc1539"/>
+            <p:cNvPr id="1535" name="rc1535"/>
             <p:cNvSpPr/>
             <p:nvPr/>
           </p:nvSpPr>
@@ -55712,7 +55572,7 @@
         </p:sp>
         <p:sp>
           <p:nvSpPr>
-            <p:cNvPr id="1540" name="rc1540"/>
+            <p:cNvPr id="1536" name="rc1536"/>
             <p:cNvSpPr/>
             <p:nvPr/>
           </p:nvSpPr>
@@ -55747,7 +55607,7 @@
         </p:sp>
         <p:sp>
           <p:nvSpPr>
-            <p:cNvPr id="1541" name="rc1541"/>
+            <p:cNvPr id="1537" name="rc1537"/>
             <p:cNvSpPr/>
             <p:nvPr/>
           </p:nvSpPr>
@@ -55782,7 +55642,7 @@
         </p:sp>
         <p:sp>
           <p:nvSpPr>
-            <p:cNvPr id="1542" name="rc1542"/>
+            <p:cNvPr id="1538" name="rc1538"/>
             <p:cNvSpPr/>
             <p:nvPr/>
           </p:nvSpPr>
@@ -55817,24 +55677,24 @@
         </p:sp>
         <p:sp>
           <p:nvSpPr>
-            <p:cNvPr id="1543" name="pl1543"/>
-            <p:cNvSpPr/>
-            <p:nvPr/>
-          </p:nvSpPr>
-          <p:spPr>
-            <a:xfrm>
-              <a:off x="2882250" y="4927853"/>
-              <a:ext cx="3674" cy="207552"/>
+            <p:cNvPr id="1539" name="pl1539"/>
+            <p:cNvSpPr/>
+            <p:nvPr/>
+          </p:nvSpPr>
+          <p:spPr>
+            <a:xfrm>
+              <a:off x="2882250" y="4929212"/>
+              <a:ext cx="3673" cy="206193"/>
             </a:xfrm>
             <a:custGeom>
               <a:avLst/>
               <a:pathLst>
-                <a:path w="3674" h="207552">
+                <a:path w="3673" h="206193">
                   <a:moveTo>
                     <a:pt x="0" y="0"/>
                   </a:moveTo>
                   <a:lnTo>
-                    <a:pt x="3674" y="207552"/>
+                    <a:pt x="3673" y="206193"/>
                   </a:lnTo>
                 </a:path>
               </a:pathLst>
@@ -55857,24 +55717,24 @@
         </p:sp>
         <p:sp>
           <p:nvSpPr>
-            <p:cNvPr id="1544" name="pl1544"/>
-            <p:cNvSpPr/>
-            <p:nvPr/>
-          </p:nvSpPr>
-          <p:spPr>
-            <a:xfrm>
-              <a:off x="3459099" y="4644472"/>
-              <a:ext cx="125021" cy="328267"/>
+            <p:cNvPr id="1540" name="pl1540"/>
+            <p:cNvSpPr/>
+            <p:nvPr/>
+          </p:nvSpPr>
+          <p:spPr>
+            <a:xfrm>
+              <a:off x="3457819" y="4646144"/>
+              <a:ext cx="126236" cy="326611"/>
             </a:xfrm>
             <a:custGeom>
               <a:avLst/>
               <a:pathLst>
-                <a:path w="125021" h="328267">
+                <a:path w="126236" h="326611">
                   <a:moveTo>
                     <a:pt x="0" y="0"/>
                   </a:moveTo>
                   <a:lnTo>
-                    <a:pt x="125021" y="328267"/>
+                    <a:pt x="126236" y="326611"/>
                   </a:lnTo>
                 </a:path>
               </a:pathLst>
@@ -55897,24 +55757,24 @@
         </p:sp>
         <p:sp>
           <p:nvSpPr>
-            <p:cNvPr id="1545" name="pl1545"/>
-            <p:cNvSpPr/>
-            <p:nvPr/>
-          </p:nvSpPr>
-          <p:spPr>
-            <a:xfrm>
-              <a:off x="4468118" y="4564007"/>
-              <a:ext cx="173779" cy="242905"/>
+            <p:cNvPr id="1541" name="pl1541"/>
+            <p:cNvSpPr/>
+            <p:nvPr/>
+          </p:nvSpPr>
+          <p:spPr>
+            <a:xfrm>
+              <a:off x="4468121" y="4564000"/>
+              <a:ext cx="173776" cy="242912"/>
             </a:xfrm>
             <a:custGeom>
               <a:avLst/>
               <a:pathLst>
-                <a:path w="173779" h="242905">
+                <a:path w="173776" h="242912">
                   <a:moveTo>
                     <a:pt x="0" y="0"/>
                   </a:moveTo>
                   <a:lnTo>
-                    <a:pt x="173779" y="242905"/>
+                    <a:pt x="173776" y="242912"/>
                   </a:lnTo>
                 </a:path>
               </a:pathLst>
@@ -55937,24 +55797,24 @@
         </p:sp>
         <p:sp>
           <p:nvSpPr>
-            <p:cNvPr id="1546" name="pl1546"/>
-            <p:cNvSpPr/>
-            <p:nvPr/>
-          </p:nvSpPr>
-          <p:spPr>
-            <a:xfrm>
-              <a:off x="5785191" y="2838477"/>
-              <a:ext cx="40372" cy="199621"/>
+            <p:cNvPr id="1542" name="pl1542"/>
+            <p:cNvSpPr/>
+            <p:nvPr/>
+          </p:nvSpPr>
+          <p:spPr>
+            <a:xfrm>
+              <a:off x="5779285" y="2839340"/>
+              <a:ext cx="45915" cy="198810"/>
             </a:xfrm>
             <a:custGeom>
               <a:avLst/>
               <a:pathLst>
-                <a:path w="40372" h="199621">
+                <a:path w="45915" h="198810">
                   <a:moveTo>
                     <a:pt x="0" y="0"/>
                   </a:moveTo>
                   <a:lnTo>
-                    <a:pt x="40372" y="199621"/>
+                    <a:pt x="45915" y="198810"/>
                   </a:lnTo>
                 </a:path>
               </a:pathLst>
@@ -55977,24 +55837,24 @@
         </p:sp>
         <p:sp>
           <p:nvSpPr>
-            <p:cNvPr id="1547" name="pl1547"/>
-            <p:cNvSpPr/>
-            <p:nvPr/>
-          </p:nvSpPr>
-          <p:spPr>
-            <a:xfrm>
-              <a:off x="5864123" y="2615021"/>
-              <a:ext cx="111659" cy="292673"/>
+            <p:cNvPr id="1543" name="pl1543"/>
+            <p:cNvSpPr/>
+            <p:nvPr/>
+          </p:nvSpPr>
+          <p:spPr>
+            <a:xfrm>
+              <a:off x="5858984" y="2616148"/>
+              <a:ext cx="116589" cy="291601"/>
             </a:xfrm>
             <a:custGeom>
               <a:avLst/>
               <a:pathLst>
-                <a:path w="111659" h="292673">
+                <a:path w="116589" h="291601">
                   <a:moveTo>
                     <a:pt x="0" y="0"/>
                   </a:moveTo>
                   <a:lnTo>
-                    <a:pt x="111659" y="292673"/>
+                    <a:pt x="116589" y="291601"/>
                   </a:lnTo>
                 </a:path>
               </a:pathLst>
@@ -56017,13 +55877,13 @@
         </p:sp>
         <p:sp>
           <p:nvSpPr>
-            <p:cNvPr id="1548" name="pg1548"/>
-            <p:cNvSpPr/>
-            <p:nvPr/>
-          </p:nvSpPr>
-          <p:spPr>
-            <a:xfrm>
-              <a:off x="2618628" y="4735921"/>
+            <p:cNvPr id="1544" name="pg1544"/>
+            <p:cNvSpPr/>
+            <p:nvPr/>
+          </p:nvSpPr>
+          <p:spPr>
+            <a:xfrm>
+              <a:off x="2618628" y="4737279"/>
               <a:ext cx="527243" cy="191932"/>
             </a:xfrm>
             <a:custGeom>
@@ -56070,7 +55930,7 @@
                     <a:pt x="527243" y="164500"/>
                   </a:lnTo>
                   <a:lnTo>
-                    <a:pt x="527243" y="27432"/>
+                    <a:pt x="527243" y="27431"/>
                   </a:lnTo>
                   <a:lnTo>
                     <a:pt x="526887" y="23031"/>
@@ -56139,7 +55999,7 @@
                     <a:pt x="88" y="25224"/>
                   </a:lnTo>
                   <a:lnTo>
-                    <a:pt x="0" y="27432"/>
+                    <a:pt x="0" y="27431"/>
                   </a:lnTo>
                   <a:lnTo>
                     <a:pt x="0" y="164500"/>
@@ -56204,13 +56064,13 @@
         </p:sp>
         <p:sp>
           <p:nvSpPr>
-            <p:cNvPr id="1549" name="tx1549"/>
-            <p:cNvSpPr/>
-            <p:nvPr/>
-          </p:nvSpPr>
-          <p:spPr>
-            <a:xfrm>
-              <a:off x="2664348" y="4781641"/>
+            <p:cNvPr id="1545" name="tx1545"/>
+            <p:cNvSpPr/>
+            <p:nvPr/>
+          </p:nvSpPr>
+          <p:spPr>
+            <a:xfrm>
+              <a:off x="2664348" y="4782999"/>
               <a:ext cx="435803" cy="100492"/>
             </a:xfrm>
             <a:prstGeom prst="rect">
@@ -56250,13 +56110,13 @@
         </p:sp>
         <p:sp>
           <p:nvSpPr>
-            <p:cNvPr id="1550" name="pg1550"/>
-            <p:cNvSpPr/>
-            <p:nvPr/>
-          </p:nvSpPr>
-          <p:spPr>
-            <a:xfrm>
-              <a:off x="3192592" y="4452539"/>
+            <p:cNvPr id="1546" name="pg1546"/>
+            <p:cNvSpPr/>
+            <p:nvPr/>
+          </p:nvSpPr>
+          <p:spPr>
+            <a:xfrm>
+              <a:off x="3191025" y="4454211"/>
               <a:ext cx="519562" cy="191932"/>
             </a:xfrm>
             <a:custGeom>
@@ -56264,7 +56124,7 @@
               <a:pathLst>
                 <a:path w="519562" h="191932">
                   <a:moveTo>
-                    <a:pt x="27431" y="191932"/>
+                    <a:pt x="27432" y="191932"/>
                   </a:moveTo>
                   <a:lnTo>
                     <a:pt x="492130" y="191932"/>
@@ -56336,7 +56196,7 @@
                     <a:pt x="492130" y="0"/>
                   </a:lnTo>
                   <a:lnTo>
-                    <a:pt x="27431" y="0"/>
+                    <a:pt x="27432" y="0"/>
                   </a:lnTo>
                   <a:lnTo>
                     <a:pt x="30738" y="200"/>
@@ -56437,13 +56297,13 @@
         </p:sp>
         <p:sp>
           <p:nvSpPr>
-            <p:cNvPr id="1551" name="tx1551"/>
-            <p:cNvSpPr/>
-            <p:nvPr/>
-          </p:nvSpPr>
-          <p:spPr>
-            <a:xfrm>
-              <a:off x="3238312" y="4498259"/>
+            <p:cNvPr id="1547" name="tx1547"/>
+            <p:cNvSpPr/>
+            <p:nvPr/>
+          </p:nvSpPr>
+          <p:spPr>
+            <a:xfrm>
+              <a:off x="3236745" y="4499931"/>
               <a:ext cx="428122" cy="100492"/>
             </a:xfrm>
             <a:prstGeom prst="rect">
@@ -56483,13 +56343,13 @@
         </p:sp>
         <p:sp>
           <p:nvSpPr>
-            <p:cNvPr id="1552" name="pg1552"/>
-            <p:cNvSpPr/>
-            <p:nvPr/>
-          </p:nvSpPr>
-          <p:spPr>
-            <a:xfrm>
-              <a:off x="4170412" y="4372075"/>
+            <p:cNvPr id="1548" name="pg1548"/>
+            <p:cNvSpPr/>
+            <p:nvPr/>
+          </p:nvSpPr>
+          <p:spPr>
+            <a:xfrm>
+              <a:off x="4170421" y="4372067"/>
               <a:ext cx="511698" cy="191932"/>
             </a:xfrm>
             <a:custGeom>
@@ -56497,7 +56357,7 @@
               <a:pathLst>
                 <a:path w="511698" h="191932">
                   <a:moveTo>
-                    <a:pt x="27432" y="191932"/>
+                    <a:pt x="27431" y="191932"/>
                   </a:moveTo>
                   <a:lnTo>
                     <a:pt x="484266" y="191932"/>
@@ -56569,7 +56429,7 @@
                     <a:pt x="484266" y="0"/>
                   </a:lnTo>
                   <a:lnTo>
-                    <a:pt x="27432" y="0"/>
+                    <a:pt x="27431" y="0"/>
                   </a:lnTo>
                   <a:lnTo>
                     <a:pt x="30738" y="200"/>
@@ -56670,13 +56530,13 @@
         </p:sp>
         <p:sp>
           <p:nvSpPr>
-            <p:cNvPr id="1553" name="tx1553"/>
-            <p:cNvSpPr/>
-            <p:nvPr/>
-          </p:nvSpPr>
-          <p:spPr>
-            <a:xfrm>
-              <a:off x="4216132" y="4417795"/>
+            <p:cNvPr id="1549" name="tx1549"/>
+            <p:cNvSpPr/>
+            <p:nvPr/>
+          </p:nvSpPr>
+          <p:spPr>
+            <a:xfrm>
+              <a:off x="4216141" y="4417787"/>
               <a:ext cx="420258" cy="100492"/>
             </a:xfrm>
             <a:prstGeom prst="rect">
@@ -56716,13 +56576,13 @@
         </p:sp>
         <p:sp>
           <p:nvSpPr>
-            <p:cNvPr id="1554" name="pg1554"/>
-            <p:cNvSpPr/>
-            <p:nvPr/>
-          </p:nvSpPr>
-          <p:spPr>
-            <a:xfrm>
-              <a:off x="5234722" y="2706428"/>
+            <p:cNvPr id="1550" name="pg1550"/>
+            <p:cNvSpPr/>
+            <p:nvPr/>
+          </p:nvSpPr>
+          <p:spPr>
+            <a:xfrm>
+              <a:off x="5228816" y="2707424"/>
               <a:ext cx="550468" cy="191932"/>
             </a:xfrm>
             <a:custGeom>
@@ -56730,7 +56590,7 @@
               <a:pathLst>
                 <a:path w="550468" h="191932">
                   <a:moveTo>
-                    <a:pt x="27431" y="191932"/>
+                    <a:pt x="27432" y="191932"/>
                   </a:moveTo>
                   <a:lnTo>
                     <a:pt x="523036" y="191932"/>
@@ -56802,7 +56662,7 @@
                     <a:pt x="523036" y="0"/>
                   </a:lnTo>
                   <a:lnTo>
-                    <a:pt x="27431" y="0"/>
+                    <a:pt x="27432" y="0"/>
                   </a:lnTo>
                   <a:lnTo>
                     <a:pt x="30738" y="200"/>
@@ -56817,7 +56677,7 @@
                     <a:pt x="17704" y="1782"/>
                   </a:lnTo>
                   <a:lnTo>
-                    <a:pt x="13715" y="3675"/>
+                    <a:pt x="13716" y="3675"/>
                   </a:lnTo>
                   <a:lnTo>
                     <a:pt x="10082" y="6183"/>
@@ -56865,7 +56725,7 @@
                     <a:pt x="10082" y="185749"/>
                   </a:lnTo>
                   <a:lnTo>
-                    <a:pt x="13715" y="188257"/>
+                    <a:pt x="13716" y="188257"/>
                   </a:lnTo>
                   <a:lnTo>
                     <a:pt x="17704" y="190149"/>
@@ -56903,13 +56763,13 @@
         </p:sp>
         <p:sp>
           <p:nvSpPr>
-            <p:cNvPr id="1555" name="tx1555"/>
-            <p:cNvSpPr/>
-            <p:nvPr/>
-          </p:nvSpPr>
-          <p:spPr>
-            <a:xfrm>
-              <a:off x="5280442" y="2752148"/>
+            <p:cNvPr id="1551" name="tx1551"/>
+            <p:cNvSpPr/>
+            <p:nvPr/>
+          </p:nvSpPr>
+          <p:spPr>
+            <a:xfrm>
+              <a:off x="5274536" y="2753144"/>
               <a:ext cx="459028" cy="100492"/>
             </a:xfrm>
             <a:prstGeom prst="rect">
@@ -56949,13 +56809,13 @@
         </p:sp>
         <p:sp>
           <p:nvSpPr>
-            <p:cNvPr id="1556" name="pg1556"/>
-            <p:cNvSpPr/>
-            <p:nvPr/>
-          </p:nvSpPr>
-          <p:spPr>
-            <a:xfrm>
-              <a:off x="5578899" y="2423089"/>
+            <p:cNvPr id="1552" name="pg1552"/>
+            <p:cNvSpPr/>
+            <p:nvPr/>
+          </p:nvSpPr>
+          <p:spPr>
+            <a:xfrm>
+              <a:off x="5572817" y="2424215"/>
               <a:ext cx="558332" cy="191932"/>
             </a:xfrm>
             <a:custGeom>
@@ -56963,7 +56823,7 @@
               <a:pathLst>
                 <a:path w="558332" h="191932">
                   <a:moveTo>
-                    <a:pt x="27432" y="191932"/>
+                    <a:pt x="27431" y="191932"/>
                   </a:moveTo>
                   <a:lnTo>
                     <a:pt x="530900" y="191932"/>
@@ -57035,7 +56895,7 @@
                     <a:pt x="530900" y="0"/>
                   </a:lnTo>
                   <a:lnTo>
-                    <a:pt x="27432" y="0"/>
+                    <a:pt x="27431" y="0"/>
                   </a:lnTo>
                   <a:lnTo>
                     <a:pt x="30738" y="200"/>
@@ -57050,7 +56910,7 @@
                     <a:pt x="17704" y="1782"/>
                   </a:lnTo>
                   <a:lnTo>
-                    <a:pt x="13716" y="3675"/>
+                    <a:pt x="13715" y="3675"/>
                   </a:lnTo>
                   <a:lnTo>
                     <a:pt x="10082" y="6183"/>
@@ -57098,7 +56958,7 @@
                     <a:pt x="10082" y="185749"/>
                   </a:lnTo>
                   <a:lnTo>
-                    <a:pt x="13716" y="188257"/>
+                    <a:pt x="13715" y="188257"/>
                   </a:lnTo>
                   <a:lnTo>
                     <a:pt x="17704" y="190149"/>
@@ -57136,13 +56996,13 @@
         </p:sp>
         <p:sp>
           <p:nvSpPr>
-            <p:cNvPr id="1557" name="tx1557"/>
-            <p:cNvSpPr/>
-            <p:nvPr/>
-          </p:nvSpPr>
-          <p:spPr>
-            <a:xfrm>
-              <a:off x="5624619" y="2468809"/>
+            <p:cNvPr id="1553" name="tx1553"/>
+            <p:cNvSpPr/>
+            <p:nvPr/>
+          </p:nvSpPr>
+          <p:spPr>
+            <a:xfrm>
+              <a:off x="5618537" y="2469935"/>
               <a:ext cx="466892" cy="100492"/>
             </a:xfrm>
             <a:prstGeom prst="rect">
@@ -57182,7 +57042,7 @@
         </p:sp>
         <p:sp>
           <p:nvSpPr>
-            <p:cNvPr id="1558" name="pl1558"/>
+            <p:cNvPr id="1554" name="pl1554"/>
             <p:cNvSpPr/>
             <p:nvPr/>
           </p:nvSpPr>
@@ -57222,7 +57082,7 @@
         </p:sp>
         <p:sp>
           <p:nvSpPr>
-            <p:cNvPr id="1559" name="tx1559"/>
+            <p:cNvPr id="1555" name="tx1555"/>
             <p:cNvSpPr/>
             <p:nvPr/>
           </p:nvSpPr>
@@ -57268,7 +57128,7 @@
         </p:sp>
         <p:sp>
           <p:nvSpPr>
-            <p:cNvPr id="1560" name="tx1560"/>
+            <p:cNvPr id="1556" name="tx1556"/>
             <p:cNvSpPr/>
             <p:nvPr/>
           </p:nvSpPr>
@@ -57314,7 +57174,7 @@
         </p:sp>
         <p:sp>
           <p:nvSpPr>
-            <p:cNvPr id="1561" name="tx1561"/>
+            <p:cNvPr id="1557" name="tx1557"/>
             <p:cNvSpPr/>
             <p:nvPr/>
           </p:nvSpPr>
@@ -57360,7 +57220,7 @@
         </p:sp>
         <p:sp>
           <p:nvSpPr>
-            <p:cNvPr id="1562" name="tx1562"/>
+            <p:cNvPr id="1558" name="tx1558"/>
             <p:cNvSpPr/>
             <p:nvPr/>
           </p:nvSpPr>
@@ -57406,7 +57266,7 @@
         </p:sp>
         <p:sp>
           <p:nvSpPr>
-            <p:cNvPr id="1563" name="tx1563"/>
+            <p:cNvPr id="1559" name="tx1559"/>
             <p:cNvSpPr/>
             <p:nvPr/>
           </p:nvSpPr>
@@ -57452,7 +57312,7 @@
         </p:sp>
         <p:sp>
           <p:nvSpPr>
-            <p:cNvPr id="1564" name="tx1564"/>
+            <p:cNvPr id="1560" name="tx1560"/>
             <p:cNvSpPr/>
             <p:nvPr/>
           </p:nvSpPr>
@@ -57498,7 +57358,7 @@
         </p:sp>
         <p:sp>
           <p:nvSpPr>
-            <p:cNvPr id="1565" name="tx1565"/>
+            <p:cNvPr id="1561" name="tx1561"/>
             <p:cNvSpPr/>
             <p:nvPr/>
           </p:nvSpPr>
@@ -57544,7 +57404,7 @@
         </p:sp>
         <p:sp>
           <p:nvSpPr>
-            <p:cNvPr id="1566" name="tx1566"/>
+            <p:cNvPr id="1562" name="tx1562"/>
             <p:cNvSpPr/>
             <p:nvPr/>
           </p:nvSpPr>
@@ -57590,7 +57450,7 @@
         </p:sp>
         <p:sp>
           <p:nvSpPr>
-            <p:cNvPr id="1567" name="tx1567"/>
+            <p:cNvPr id="1563" name="tx1563"/>
             <p:cNvSpPr/>
             <p:nvPr/>
           </p:nvSpPr>
@@ -57636,7 +57496,7 @@
         </p:sp>
         <p:sp>
           <p:nvSpPr>
-            <p:cNvPr id="1568" name="tx1568"/>
+            <p:cNvPr id="1564" name="tx1564"/>
             <p:cNvSpPr/>
             <p:nvPr/>
           </p:nvSpPr>
@@ -57682,7 +57542,7 @@
         </p:sp>
         <p:sp>
           <p:nvSpPr>
-            <p:cNvPr id="1569" name="tx1569"/>
+            <p:cNvPr id="1565" name="tx1565"/>
             <p:cNvSpPr/>
             <p:nvPr/>
           </p:nvSpPr>
@@ -57728,7 +57588,7 @@
         </p:sp>
         <p:sp>
           <p:nvSpPr>
-            <p:cNvPr id="1570" name="tx1570"/>
+            <p:cNvPr id="1566" name="tx1566"/>
             <p:cNvSpPr/>
             <p:nvPr/>
           </p:nvSpPr>
@@ -57774,7 +57634,7 @@
         </p:sp>
         <p:sp>
           <p:nvSpPr>
-            <p:cNvPr id="1571" name="tx1571"/>
+            <p:cNvPr id="1567" name="tx1567"/>
             <p:cNvSpPr/>
             <p:nvPr/>
           </p:nvSpPr>
@@ -57820,7 +57680,7 @@
         </p:sp>
         <p:sp>
           <p:nvSpPr>
-            <p:cNvPr id="1572" name="tx1572"/>
+            <p:cNvPr id="1568" name="tx1568"/>
             <p:cNvSpPr/>
             <p:nvPr/>
           </p:nvSpPr>
@@ -57866,7 +57726,7 @@
         </p:sp>
         <p:sp>
           <p:nvSpPr>
-            <p:cNvPr id="1573" name="tx1573"/>
+            <p:cNvPr id="1569" name="tx1569"/>
             <p:cNvSpPr/>
             <p:nvPr/>
           </p:nvSpPr>
@@ -57912,7 +57772,7 @@
         </p:sp>
         <p:sp>
           <p:nvSpPr>
-            <p:cNvPr id="1574" name="tx1574"/>
+            <p:cNvPr id="1570" name="tx1570"/>
             <p:cNvSpPr/>
             <p:nvPr/>
           </p:nvSpPr>
@@ -57958,7 +57818,7 @@
         </p:sp>
         <p:sp>
           <p:nvSpPr>
-            <p:cNvPr id="1575" name="tx1575"/>
+            <p:cNvPr id="1571" name="tx1571"/>
             <p:cNvSpPr/>
             <p:nvPr/>
           </p:nvSpPr>
@@ -58004,7 +57864,7 @@
         </p:sp>
         <p:sp>
           <p:nvSpPr>
-            <p:cNvPr id="1576" name="tx1576"/>
+            <p:cNvPr id="1572" name="tx1572"/>
             <p:cNvSpPr/>
             <p:nvPr/>
           </p:nvSpPr>
@@ -58050,7 +57910,7 @@
         </p:sp>
         <p:sp>
           <p:nvSpPr>
-            <p:cNvPr id="1577" name="pl1577"/>
+            <p:cNvPr id="1573" name="pl1573"/>
             <p:cNvSpPr/>
             <p:nvPr/>
           </p:nvSpPr>
@@ -58090,7 +57950,7 @@
         </p:sp>
         <p:sp>
           <p:nvSpPr>
-            <p:cNvPr id="1578" name="pl1578"/>
+            <p:cNvPr id="1574" name="pl1574"/>
             <p:cNvSpPr/>
             <p:nvPr/>
           </p:nvSpPr>
@@ -58130,7 +57990,7 @@
         </p:sp>
         <p:sp>
           <p:nvSpPr>
-            <p:cNvPr id="1579" name="pl1579"/>
+            <p:cNvPr id="1575" name="pl1575"/>
             <p:cNvSpPr/>
             <p:nvPr/>
           </p:nvSpPr>
@@ -58170,7 +58030,7 @@
         </p:sp>
         <p:sp>
           <p:nvSpPr>
-            <p:cNvPr id="1580" name="pl1580"/>
+            <p:cNvPr id="1576" name="pl1576"/>
             <p:cNvSpPr/>
             <p:nvPr/>
           </p:nvSpPr>
@@ -58210,7 +58070,7 @@
         </p:sp>
         <p:sp>
           <p:nvSpPr>
-            <p:cNvPr id="1581" name="pl1581"/>
+            <p:cNvPr id="1577" name="pl1577"/>
             <p:cNvSpPr/>
             <p:nvPr/>
           </p:nvSpPr>
@@ -58250,7 +58110,7 @@
         </p:sp>
         <p:sp>
           <p:nvSpPr>
-            <p:cNvPr id="1582" name="pl1582"/>
+            <p:cNvPr id="1578" name="pl1578"/>
             <p:cNvSpPr/>
             <p:nvPr/>
           </p:nvSpPr>
@@ -58290,7 +58150,7 @@
         </p:sp>
         <p:sp>
           <p:nvSpPr>
-            <p:cNvPr id="1583" name="pl1583"/>
+            <p:cNvPr id="1579" name="pl1579"/>
             <p:cNvSpPr/>
             <p:nvPr/>
           </p:nvSpPr>
@@ -58330,7 +58190,7 @@
         </p:sp>
         <p:sp>
           <p:nvSpPr>
-            <p:cNvPr id="1584" name="pl1584"/>
+            <p:cNvPr id="1580" name="pl1580"/>
             <p:cNvSpPr/>
             <p:nvPr/>
           </p:nvSpPr>
@@ -58370,7 +58230,7 @@
         </p:sp>
         <p:sp>
           <p:nvSpPr>
-            <p:cNvPr id="1585" name="pl1585"/>
+            <p:cNvPr id="1581" name="pl1581"/>
             <p:cNvSpPr/>
             <p:nvPr/>
           </p:nvSpPr>
@@ -58410,7 +58270,7 @@
         </p:sp>
         <p:sp>
           <p:nvSpPr>
-            <p:cNvPr id="1586" name="pl1586"/>
+            <p:cNvPr id="1582" name="pl1582"/>
             <p:cNvSpPr/>
             <p:nvPr/>
           </p:nvSpPr>
@@ -58450,7 +58310,7 @@
         </p:sp>
         <p:sp>
           <p:nvSpPr>
-            <p:cNvPr id="1587" name="pl1587"/>
+            <p:cNvPr id="1583" name="pl1583"/>
             <p:cNvSpPr/>
             <p:nvPr/>
           </p:nvSpPr>
@@ -58490,7 +58350,7 @@
         </p:sp>
         <p:sp>
           <p:nvSpPr>
-            <p:cNvPr id="1588" name="pl1588"/>
+            <p:cNvPr id="1584" name="pl1584"/>
             <p:cNvSpPr/>
             <p:nvPr/>
           </p:nvSpPr>
@@ -58530,7 +58390,7 @@
         </p:sp>
         <p:sp>
           <p:nvSpPr>
-            <p:cNvPr id="1589" name="pl1589"/>
+            <p:cNvPr id="1585" name="pl1585"/>
             <p:cNvSpPr/>
             <p:nvPr/>
           </p:nvSpPr>
@@ -58570,7 +58430,7 @@
         </p:sp>
         <p:sp>
           <p:nvSpPr>
-            <p:cNvPr id="1590" name="pl1590"/>
+            <p:cNvPr id="1586" name="pl1586"/>
             <p:cNvSpPr/>
             <p:nvPr/>
           </p:nvSpPr>
@@ -58610,7 +58470,7 @@
         </p:sp>
         <p:sp>
           <p:nvSpPr>
-            <p:cNvPr id="1591" name="pl1591"/>
+            <p:cNvPr id="1587" name="pl1587"/>
             <p:cNvSpPr/>
             <p:nvPr/>
           </p:nvSpPr>
@@ -58650,7 +58510,7 @@
         </p:sp>
         <p:sp>
           <p:nvSpPr>
-            <p:cNvPr id="1592" name="pl1592"/>
+            <p:cNvPr id="1588" name="pl1588"/>
             <p:cNvSpPr/>
             <p:nvPr/>
           </p:nvSpPr>
@@ -58690,7 +58550,7 @@
         </p:sp>
         <p:sp>
           <p:nvSpPr>
-            <p:cNvPr id="1593" name="tx1593"/>
+            <p:cNvPr id="1589" name="tx1589"/>
             <p:cNvSpPr/>
             <p:nvPr/>
           </p:nvSpPr>
@@ -58736,7 +58596,7 @@
         </p:sp>
         <p:sp>
           <p:nvSpPr>
-            <p:cNvPr id="1594" name="tx1594"/>
+            <p:cNvPr id="1590" name="tx1590"/>
             <p:cNvSpPr/>
             <p:nvPr/>
           </p:nvSpPr>
@@ -58782,7 +58642,7 @@
         </p:sp>
         <p:sp>
           <p:nvSpPr>
-            <p:cNvPr id="1595" name="tx1595"/>
+            <p:cNvPr id="1591" name="tx1591"/>
             <p:cNvSpPr/>
             <p:nvPr/>
           </p:nvSpPr>
@@ -58828,7 +58688,7 @@
         </p:sp>
         <p:sp>
           <p:nvSpPr>
-            <p:cNvPr id="1596" name="tx1596"/>
+            <p:cNvPr id="1592" name="tx1592"/>
             <p:cNvSpPr/>
             <p:nvPr/>
           </p:nvSpPr>
@@ -58874,7 +58734,7 @@
         </p:sp>
         <p:sp>
           <p:nvSpPr>
-            <p:cNvPr id="1597" name="tx1597"/>
+            <p:cNvPr id="1593" name="tx1593"/>
             <p:cNvSpPr/>
             <p:nvPr/>
           </p:nvSpPr>
@@ -58920,7 +58780,7 @@
         </p:sp>
         <p:sp>
           <p:nvSpPr>
-            <p:cNvPr id="1598" name="tx1598"/>
+            <p:cNvPr id="1594" name="tx1594"/>
             <p:cNvSpPr/>
             <p:nvPr/>
           </p:nvSpPr>
@@ -58966,7 +58826,7 @@
         </p:sp>
         <p:sp>
           <p:nvSpPr>
-            <p:cNvPr id="1599" name="tx1599"/>
+            <p:cNvPr id="1595" name="tx1595"/>
             <p:cNvSpPr/>
             <p:nvPr/>
           </p:nvSpPr>
@@ -59012,7 +58872,7 @@
         </p:sp>
         <p:sp>
           <p:nvSpPr>
-            <p:cNvPr id="1600" name="tx1600"/>
+            <p:cNvPr id="1596" name="tx1596"/>
             <p:cNvSpPr/>
             <p:nvPr/>
           </p:nvSpPr>
@@ -59058,7 +58918,7 @@
         </p:sp>
         <p:sp>
           <p:nvSpPr>
-            <p:cNvPr id="1601" name="tx1601"/>
+            <p:cNvPr id="1597" name="tx1597"/>
             <p:cNvSpPr/>
             <p:nvPr/>
           </p:nvSpPr>
@@ -59104,7 +58964,7 @@
         </p:sp>
         <p:sp>
           <p:nvSpPr>
-            <p:cNvPr id="1602" name="tx1602"/>
+            <p:cNvPr id="1598" name="tx1598"/>
             <p:cNvSpPr/>
             <p:nvPr/>
           </p:nvSpPr>
@@ -59150,7 +59010,7 @@
         </p:sp>
         <p:sp>
           <p:nvSpPr>
-            <p:cNvPr id="1603" name="tx1603"/>
+            <p:cNvPr id="1599" name="tx1599"/>
             <p:cNvSpPr/>
             <p:nvPr/>
           </p:nvSpPr>
@@ -59196,7 +59056,7 @@
         </p:sp>
         <p:sp>
           <p:nvSpPr>
-            <p:cNvPr id="1604" name="tx1604"/>
+            <p:cNvPr id="1600" name="tx1600"/>
             <p:cNvSpPr/>
             <p:nvPr/>
           </p:nvSpPr>
@@ -59242,7 +59102,7 @@
         </p:sp>
         <p:sp>
           <p:nvSpPr>
-            <p:cNvPr id="1605" name="tx1605"/>
+            <p:cNvPr id="1601" name="tx1601"/>
             <p:cNvSpPr/>
             <p:nvPr/>
           </p:nvSpPr>
@@ -59288,7 +59148,7 @@
         </p:sp>
         <p:sp>
           <p:nvSpPr>
-            <p:cNvPr id="1606" name="tx1606"/>
+            <p:cNvPr id="1602" name="tx1602"/>
             <p:cNvSpPr/>
             <p:nvPr/>
           </p:nvSpPr>
@@ -59334,7 +59194,7 @@
         </p:sp>
         <p:sp>
           <p:nvSpPr>
-            <p:cNvPr id="1607" name="tx1607"/>
+            <p:cNvPr id="1603" name="tx1603"/>
             <p:cNvSpPr/>
             <p:nvPr/>
           </p:nvSpPr>
@@ -59380,7 +59240,7 @@
         </p:sp>
         <p:sp>
           <p:nvSpPr>
-            <p:cNvPr id="1608" name="tx1608"/>
+            <p:cNvPr id="1604" name="tx1604"/>
             <p:cNvSpPr/>
             <p:nvPr/>
           </p:nvSpPr>
@@ -59426,7 +59286,7 @@
         </p:sp>
         <p:sp>
           <p:nvSpPr>
-            <p:cNvPr id="1609" name="tx1609"/>
+            <p:cNvPr id="1605" name="tx1605"/>
             <p:cNvSpPr/>
             <p:nvPr/>
           </p:nvSpPr>
@@ -59472,7 +59332,7 @@
         </p:sp>
         <p:sp>
           <p:nvSpPr>
-            <p:cNvPr id="1610" name="tx1610"/>
+            <p:cNvPr id="1606" name="tx1606"/>
             <p:cNvSpPr/>
             <p:nvPr/>
           </p:nvSpPr>
@@ -59518,7 +59378,7 @@
         </p:sp>
         <p:sp>
           <p:nvSpPr>
-            <p:cNvPr id="1611" name="tx1611"/>
+            <p:cNvPr id="1607" name="tx1607"/>
             <p:cNvSpPr/>
             <p:nvPr/>
           </p:nvSpPr>
@@ -59564,7 +59424,7 @@
         </p:sp>
         <p:sp>
           <p:nvSpPr>
-            <p:cNvPr id="1612" name="tx1612"/>
+            <p:cNvPr id="1608" name="tx1608"/>
             <p:cNvSpPr/>
             <p:nvPr/>
           </p:nvSpPr>
@@ -59610,7 +59470,7 @@
         </p:sp>
         <p:sp>
           <p:nvSpPr>
-            <p:cNvPr id="1613" name="tx1613"/>
+            <p:cNvPr id="1609" name="tx1609"/>
             <p:cNvSpPr/>
             <p:nvPr/>
           </p:nvSpPr>
@@ -59656,7 +59516,7 @@
         </p:sp>
         <p:sp>
           <p:nvSpPr>
-            <p:cNvPr id="1614" name="tx1614"/>
+            <p:cNvPr id="1610" name="tx1610"/>
             <p:cNvSpPr/>
             <p:nvPr/>
           </p:nvSpPr>
@@ -59702,7 +59562,7 @@
         </p:sp>
         <p:sp>
           <p:nvSpPr>
-            <p:cNvPr id="1615" name="tx1615"/>
+            <p:cNvPr id="1611" name="tx1611"/>
             <p:cNvSpPr/>
             <p:nvPr/>
           </p:nvSpPr>
@@ -59748,7 +59608,7 @@
         </p:sp>
         <p:sp>
           <p:nvSpPr>
-            <p:cNvPr id="1616" name="tx1616"/>
+            <p:cNvPr id="1612" name="tx1612"/>
             <p:cNvSpPr/>
             <p:nvPr/>
           </p:nvSpPr>
@@ -59794,7 +59654,7 @@
         </p:sp>
         <p:sp>
           <p:nvSpPr>
-            <p:cNvPr id="1617" name="tx1617"/>
+            <p:cNvPr id="1613" name="tx1613"/>
             <p:cNvSpPr/>
             <p:nvPr/>
           </p:nvSpPr>
@@ -59840,7 +59700,7 @@
         </p:sp>
         <p:sp>
           <p:nvSpPr>
-            <p:cNvPr id="1618" name="tx1618"/>
+            <p:cNvPr id="1614" name="tx1614"/>
             <p:cNvSpPr/>
             <p:nvPr/>
           </p:nvSpPr>
@@ -59886,7 +59746,7 @@
         </p:sp>
         <p:sp>
           <p:nvSpPr>
-            <p:cNvPr id="1619" name="tx1619"/>
+            <p:cNvPr id="1615" name="tx1615"/>
             <p:cNvSpPr/>
             <p:nvPr/>
           </p:nvSpPr>
@@ -59932,7 +59792,7 @@
         </p:sp>
         <p:sp>
           <p:nvSpPr>
-            <p:cNvPr id="1620" name="tx1620"/>
+            <p:cNvPr id="1616" name="tx1616"/>
             <p:cNvSpPr/>
             <p:nvPr/>
           </p:nvSpPr>
@@ -59978,7 +59838,7 @@
         </p:sp>
         <p:sp>
           <p:nvSpPr>
-            <p:cNvPr id="1621" name="tx1621"/>
+            <p:cNvPr id="1617" name="tx1617"/>
             <p:cNvSpPr/>
             <p:nvPr/>
           </p:nvSpPr>
@@ -60024,7 +59884,7 @@
         </p:sp>
         <p:sp>
           <p:nvSpPr>
-            <p:cNvPr id="1622" name="tx1622"/>
+            <p:cNvPr id="1618" name="tx1618"/>
             <p:cNvSpPr/>
             <p:nvPr/>
           </p:nvSpPr>
@@ -60070,7 +59930,7 @@
         </p:sp>
         <p:sp>
           <p:nvSpPr>
-            <p:cNvPr id="1623" name="tx1623"/>
+            <p:cNvPr id="1619" name="tx1619"/>
             <p:cNvSpPr/>
             <p:nvPr/>
           </p:nvSpPr>
@@ -60372,16 +60232,19 @@
           <p:spPr>
             <a:xfrm>
               <a:off x="3147820" y="5516533"/>
-              <a:ext cx="101935" cy="186280"/>
+              <a:ext cx="132471" cy="204506"/>
             </a:xfrm>
             <a:custGeom>
               <a:avLst/>
               <a:pathLst>
-                <a:path w="101935" h="186280">
+                <a:path w="132471" h="204506">
                   <a:moveTo>
-                    <a:pt x="15596" y="186280"/>
+                    <a:pt x="15317" y="204506"/>
                   </a:moveTo>
                   <a:lnTo>
+                    <a:pt x="16373" y="190905"/>
+                  </a:lnTo>
+                  <a:lnTo>
                     <a:pt x="0" y="93523"/>
                   </a:lnTo>
                   <a:lnTo>
@@ -60394,7 +60257,10 @@
                     <a:pt x="47017" y="150123"/>
                   </a:lnTo>
                   <a:lnTo>
-                    <a:pt x="101935" y="185048"/>
+                    <a:pt x="132471" y="204506"/>
+                  </a:lnTo>
+                  <a:lnTo>
+                    <a:pt x="132471" y="204506"/>
                   </a:lnTo>
                 </a:path>
               </a:pathLst>
@@ -60423,99 +60289,105 @@
           </p:nvSpPr>
           <p:spPr>
             <a:xfrm>
-              <a:off x="3362218" y="5097035"/>
-              <a:ext cx="592216" cy="603094"/>
+              <a:off x="3307155" y="5097035"/>
+              <a:ext cx="660121" cy="624003"/>
             </a:xfrm>
             <a:custGeom>
               <a:avLst/>
               <a:pathLst>
-                <a:path w="592216" h="603094">
+                <a:path w="660121" h="624003">
                   <a:moveTo>
-                    <a:pt x="0" y="603094"/>
+                    <a:pt x="0" y="624003"/>
                   </a:moveTo>
                   <a:lnTo>
-                    <a:pt x="28424" y="576766"/>
-                  </a:lnTo>
-                  <a:lnTo>
-                    <a:pt x="59668" y="512782"/>
-                  </a:lnTo>
-                  <a:lnTo>
-                    <a:pt x="107737" y="508256"/>
-                  </a:lnTo>
-                  <a:lnTo>
-                    <a:pt x="179878" y="529886"/>
-                  </a:lnTo>
-                  <a:lnTo>
-                    <a:pt x="146643" y="457802"/>
-                  </a:lnTo>
-                  <a:lnTo>
-                    <a:pt x="184197" y="480241"/>
-                  </a:lnTo>
-                  <a:lnTo>
-                    <a:pt x="239401" y="500871"/>
-                  </a:lnTo>
-                  <a:lnTo>
-                    <a:pt x="246273" y="433218"/>
-                  </a:lnTo>
-                  <a:lnTo>
-                    <a:pt x="241053" y="370567"/>
-                  </a:lnTo>
-                  <a:lnTo>
-                    <a:pt x="312668" y="414256"/>
-                  </a:lnTo>
-                  <a:lnTo>
-                    <a:pt x="393071" y="439173"/>
-                  </a:lnTo>
-                  <a:lnTo>
-                    <a:pt x="444745" y="471666"/>
-                  </a:lnTo>
-                  <a:lnTo>
-                    <a:pt x="493152" y="532982"/>
-                  </a:lnTo>
-                  <a:lnTo>
-                    <a:pt x="457363" y="381716"/>
-                  </a:lnTo>
-                  <a:lnTo>
-                    <a:pt x="412561" y="269373"/>
-                  </a:lnTo>
-                  <a:lnTo>
-                    <a:pt x="371327" y="224351"/>
-                  </a:lnTo>
-                  <a:lnTo>
-                    <a:pt x="360324" y="180805"/>
-                  </a:lnTo>
-                  <a:lnTo>
-                    <a:pt x="380566" y="105100"/>
-                  </a:lnTo>
-                  <a:lnTo>
-                    <a:pt x="385711" y="85900"/>
-                  </a:lnTo>
-                  <a:lnTo>
-                    <a:pt x="375195" y="57695"/>
-                  </a:lnTo>
-                  <a:lnTo>
-                    <a:pt x="381429" y="20962"/>
-                  </a:lnTo>
-                  <a:lnTo>
-                    <a:pt x="395925" y="0"/>
-                  </a:lnTo>
-                  <a:lnTo>
-                    <a:pt x="417932" y="25774"/>
-                  </a:lnTo>
-                  <a:lnTo>
-                    <a:pt x="436633" y="90331"/>
-                  </a:lnTo>
-                  <a:lnTo>
-                    <a:pt x="440088" y="105958"/>
-                  </a:lnTo>
-                  <a:lnTo>
-                    <a:pt x="501076" y="378619"/>
-                  </a:lnTo>
-                  <a:lnTo>
-                    <a:pt x="563791" y="541892"/>
-                  </a:lnTo>
-                  <a:lnTo>
-                    <a:pt x="592216" y="598311"/>
+                    <a:pt x="41577" y="615595"/>
+                  </a:lnTo>
+                  <a:lnTo>
+                    <a:pt x="83487" y="576766"/>
+                  </a:lnTo>
+                  <a:lnTo>
+                    <a:pt x="114732" y="512782"/>
+                  </a:lnTo>
+                  <a:lnTo>
+                    <a:pt x="162801" y="508256"/>
+                  </a:lnTo>
+                  <a:lnTo>
+                    <a:pt x="234942" y="529886"/>
+                  </a:lnTo>
+                  <a:lnTo>
+                    <a:pt x="201707" y="457802"/>
+                  </a:lnTo>
+                  <a:lnTo>
+                    <a:pt x="239260" y="480241"/>
+                  </a:lnTo>
+                  <a:lnTo>
+                    <a:pt x="294464" y="500871"/>
+                  </a:lnTo>
+                  <a:lnTo>
+                    <a:pt x="301337" y="433218"/>
+                  </a:lnTo>
+                  <a:lnTo>
+                    <a:pt x="296117" y="370567"/>
+                  </a:lnTo>
+                  <a:lnTo>
+                    <a:pt x="367732" y="414256"/>
+                  </a:lnTo>
+                  <a:lnTo>
+                    <a:pt x="448135" y="439173"/>
+                  </a:lnTo>
+                  <a:lnTo>
+                    <a:pt x="499809" y="471666"/>
+                  </a:lnTo>
+                  <a:lnTo>
+                    <a:pt x="548215" y="532982"/>
+                  </a:lnTo>
+                  <a:lnTo>
+                    <a:pt x="512427" y="381716"/>
+                  </a:lnTo>
+                  <a:lnTo>
+                    <a:pt x="467625" y="269373"/>
+                  </a:lnTo>
+                  <a:lnTo>
+                    <a:pt x="426391" y="224351"/>
+                  </a:lnTo>
+                  <a:lnTo>
+                    <a:pt x="415388" y="180805"/>
+                  </a:lnTo>
+                  <a:lnTo>
+                    <a:pt x="435629" y="105100"/>
+                  </a:lnTo>
+                  <a:lnTo>
+                    <a:pt x="440774" y="85900"/>
+                  </a:lnTo>
+                  <a:lnTo>
+                    <a:pt x="430259" y="57695"/>
+                  </a:lnTo>
+                  <a:lnTo>
+                    <a:pt x="436493" y="20962"/>
+                  </a:lnTo>
+                  <a:lnTo>
+                    <a:pt x="450989" y="0"/>
+                  </a:lnTo>
+                  <a:lnTo>
+                    <a:pt x="472995" y="25774"/>
+                  </a:lnTo>
+                  <a:lnTo>
+                    <a:pt x="491697" y="90331"/>
+                  </a:lnTo>
+                  <a:lnTo>
+                    <a:pt x="495152" y="105958"/>
+                  </a:lnTo>
+                  <a:lnTo>
+                    <a:pt x="556139" y="378619"/>
+                  </a:lnTo>
+                  <a:lnTo>
+                    <a:pt x="618854" y="541892"/>
+                  </a:lnTo>
+                  <a:lnTo>
+                    <a:pt x="660121" y="624003"/>
+                  </a:lnTo>
+                  <a:lnTo>
+                    <a:pt x="660121" y="624003"/>
                   </a:lnTo>
                 </a:path>
               </a:pathLst>
@@ -60545,14 +60417,14 @@
           <p:spPr>
             <a:xfrm>
               <a:off x="2706637" y="1896563"/>
-              <a:ext cx="1751847" cy="3798672"/>
+              <a:ext cx="1751847" cy="3824476"/>
             </a:xfrm>
             <a:custGeom>
               <a:avLst/>
               <a:pathLst>
-                <a:path w="1751847" h="3798672">
+                <a:path w="1751847" h="3824476">
                   <a:moveTo>
-                    <a:pt x="1276986" y="3798672"/>
+                    <a:pt x="1288376" y="3824476"/>
                   </a:moveTo>
                   <a:lnTo>
                     <a:pt x="1196576" y="3619874"/>
@@ -61320,7 +61192,10 @@
                     <a:pt x="1646433" y="43310"/>
                   </a:lnTo>
                   <a:lnTo>
-                    <a:pt x="1684430" y="0"/>
+                    <a:pt x="1684442" y="0"/>
+                  </a:lnTo>
+                  <a:lnTo>
+                    <a:pt x="1684442" y="0"/>
                   </a:lnTo>
                 </a:path>
               </a:pathLst>
@@ -61357,7 +61232,7 @@
               <a:pathLst>
                 <a:path w="1082264" h="973826">
                   <a:moveTo>
-                    <a:pt x="326570" y="0"/>
+                    <a:pt x="326571" y="0"/>
                   </a:moveTo>
                   <a:lnTo>
                     <a:pt x="323338" y="7149"/>
@@ -61454,6 +61329,9 @@
                   </a:lnTo>
                   <a:lnTo>
                     <a:pt x="1081812" y="1003"/>
+                  </a:lnTo>
+                  <a:lnTo>
+                    <a:pt x="1082264" y="0"/>
                   </a:lnTo>
                   <a:lnTo>
                     <a:pt x="1082264" y="0"/>
@@ -61486,14 +61364,14 @@
           <p:spPr>
             <a:xfrm>
               <a:off x="5190596" y="1896563"/>
-              <a:ext cx="28664" cy="147362"/>
+              <a:ext cx="28666" cy="147362"/>
             </a:xfrm>
             <a:custGeom>
               <a:avLst/>
               <a:pathLst>
-                <a:path w="28664" h="147362">
+                <a:path w="28666" h="147362">
                   <a:moveTo>
-                    <a:pt x="9999" y="0"/>
+                    <a:pt x="10004" y="0"/>
                   </a:moveTo>
                   <a:lnTo>
                     <a:pt x="0" y="107390"/>
@@ -61505,7 +61383,10 @@
                     <a:pt x="26963" y="15724"/>
                   </a:lnTo>
                   <a:lnTo>
-                    <a:pt x="28664" y="0"/>
+                    <a:pt x="28666" y="0"/>
+                  </a:lnTo>
+                  <a:lnTo>
+                    <a:pt x="28666" y="0"/>
                   </a:lnTo>
                 </a:path>
               </a:pathLst>
@@ -61948,14 +61829,14 @@
           <p:spPr>
             <a:xfrm>
               <a:off x="3376095" y="3807884"/>
-              <a:ext cx="420893" cy="2"/>
+              <a:ext cx="420896" cy="0"/>
             </a:xfrm>
             <a:custGeom>
               <a:avLst/>
               <a:pathLst>
-                <a:path w="420893" h="2">
+                <a:path w="420896" h="0">
                   <a:moveTo>
-                    <a:pt x="420893" y="2"/>
+                    <a:pt x="420896" y="0"/>
                   </a:moveTo>
                   <a:lnTo>
                     <a:pt x="0" y="0"/>
@@ -61988,14 +61869,14 @@
           <p:spPr>
             <a:xfrm>
               <a:off x="3347277" y="4523109"/>
-              <a:ext cx="409282" cy="1"/>
+              <a:ext cx="409280" cy="2"/>
             </a:xfrm>
             <a:custGeom>
               <a:avLst/>
               <a:pathLst>
-                <a:path w="409282" h="1">
+                <a:path w="409280" h="2">
                   <a:moveTo>
-                    <a:pt x="409282" y="1"/>
+                    <a:pt x="409280" y="2"/>
                   </a:moveTo>
                   <a:lnTo>
                     <a:pt x="0" y="0"/>
@@ -62027,7 +61908,7 @@
           </p:nvSpPr>
           <p:spPr>
             <a:xfrm>
-              <a:off x="3796988" y="3711920"/>
+              <a:off x="3796991" y="3711918"/>
               <a:ext cx="667694" cy="191932"/>
             </a:xfrm>
             <a:custGeom>
@@ -62035,7 +61916,7 @@
               <a:pathLst>
                 <a:path w="667694" h="191932">
                   <a:moveTo>
-                    <a:pt x="27431" y="191932"/>
+                    <a:pt x="27432" y="191932"/>
                   </a:moveTo>
                   <a:lnTo>
                     <a:pt x="640262" y="191932"/>
@@ -62074,7 +61955,7 @@
                     <a:pt x="667694" y="164500"/>
                   </a:lnTo>
                   <a:lnTo>
-                    <a:pt x="667694" y="27432"/>
+                    <a:pt x="667694" y="27431"/>
                   </a:lnTo>
                   <a:lnTo>
                     <a:pt x="667339" y="23031"/>
@@ -62107,7 +61988,7 @@
                     <a:pt x="640262" y="0"/>
                   </a:lnTo>
                   <a:lnTo>
-                    <a:pt x="27431" y="0"/>
+                    <a:pt x="27432" y="0"/>
                   </a:lnTo>
                   <a:lnTo>
                     <a:pt x="30738" y="200"/>
@@ -62143,7 +62024,7 @@
                     <a:pt x="88" y="25224"/>
                   </a:lnTo>
                   <a:lnTo>
-                    <a:pt x="0" y="27432"/>
+                    <a:pt x="0" y="27431"/>
                   </a:lnTo>
                   <a:lnTo>
                     <a:pt x="0" y="164500"/>
@@ -62214,7 +62095,7 @@
           </p:nvSpPr>
           <p:spPr>
             <a:xfrm>
-              <a:off x="3842708" y="3757640"/>
+              <a:off x="3842711" y="3757638"/>
               <a:ext cx="576254" cy="100492"/>
             </a:xfrm>
             <a:prstGeom prst="rect">
@@ -62260,7 +62141,7 @@
           </p:nvSpPr>
           <p:spPr>
             <a:xfrm>
-              <a:off x="3756560" y="4427144"/>
+              <a:off x="3756558" y="4427146"/>
               <a:ext cx="690920" cy="191932"/>
             </a:xfrm>
             <a:custGeom>
@@ -62307,7 +62188,7 @@
                     <a:pt x="690920" y="164500"/>
                   </a:lnTo>
                   <a:lnTo>
-                    <a:pt x="690920" y="27432"/>
+                    <a:pt x="690920" y="27431"/>
                   </a:lnTo>
                   <a:lnTo>
                     <a:pt x="690565" y="23031"/>
@@ -62376,7 +62257,7 @@
                     <a:pt x="88" y="25224"/>
                   </a:lnTo>
                   <a:lnTo>
-                    <a:pt x="0" y="27432"/>
+                    <a:pt x="0" y="27431"/>
                   </a:lnTo>
                   <a:lnTo>
                     <a:pt x="0" y="164500"/>
@@ -62447,7 +62328,7 @@
           </p:nvSpPr>
           <p:spPr>
             <a:xfrm>
-              <a:off x="3802280" y="4472864"/>
+              <a:off x="3802278" y="4472866"/>
               <a:ext cx="599480" cy="100492"/>
             </a:xfrm>
             <a:prstGeom prst="rect">
@@ -62493,18 +62374,18 @@
           </p:nvSpPr>
           <p:spPr>
             <a:xfrm>
-              <a:off x="3049624" y="3651543"/>
-              <a:ext cx="185611" cy="147492"/>
+              <a:off x="3049619" y="3651547"/>
+              <a:ext cx="185616" cy="147488"/>
             </a:xfrm>
             <a:custGeom>
               <a:avLst/>
               <a:pathLst>
-                <a:path w="185611" h="147492">
+                <a:path w="185616" h="147488">
                   <a:moveTo>
                     <a:pt x="0" y="0"/>
                   </a:moveTo>
                   <a:lnTo>
-                    <a:pt x="185611" y="147492"/>
+                    <a:pt x="185616" y="147488"/>
                   </a:lnTo>
                 </a:path>
               </a:pathLst>
@@ -62533,18 +62414,18 @@
           </p:nvSpPr>
           <p:spPr>
             <a:xfrm>
-              <a:off x="3080122" y="4375697"/>
-              <a:ext cx="127767" cy="137046"/>
+              <a:off x="3080122" y="4375691"/>
+              <a:ext cx="127768" cy="137051"/>
             </a:xfrm>
             <a:custGeom>
               <a:avLst/>
               <a:pathLst>
-                <a:path w="127767" h="137046">
+                <a:path w="127768" h="137051">
                   <a:moveTo>
                     <a:pt x="0" y="0"/>
                   </a:moveTo>
                   <a:lnTo>
-                    <a:pt x="127767" y="137046"/>
+                    <a:pt x="127768" y="137051"/>
                   </a:lnTo>
                 </a:path>
               </a:pathLst>
@@ -62573,7 +62454,7 @@
           </p:nvSpPr>
           <p:spPr>
             <a:xfrm>
-              <a:off x="2366385" y="3536282"/>
+              <a:off x="2366379" y="3536287"/>
               <a:ext cx="683239" cy="191932"/>
             </a:xfrm>
             <a:custGeom>
@@ -62668,7 +62549,7 @@
                     <a:pt x="17704" y="1782"/>
                   </a:lnTo>
                   <a:lnTo>
-                    <a:pt x="13716" y="3675"/>
+                    <a:pt x="13715" y="3675"/>
                   </a:lnTo>
                   <a:lnTo>
                     <a:pt x="10082" y="6183"/>
@@ -62716,7 +62597,7 @@
                     <a:pt x="10082" y="185749"/>
                   </a:lnTo>
                   <a:lnTo>
-                    <a:pt x="13716" y="188257"/>
+                    <a:pt x="13715" y="188257"/>
                   </a:lnTo>
                   <a:lnTo>
                     <a:pt x="17704" y="190149"/>
@@ -62760,7 +62641,7 @@
           </p:nvSpPr>
           <p:spPr>
             <a:xfrm>
-              <a:off x="2412105" y="3582002"/>
+              <a:off x="2412099" y="3582007"/>
               <a:ext cx="591799" cy="100492"/>
             </a:xfrm>
             <a:prstGeom prst="rect">
@@ -62806,7 +62687,7 @@
           </p:nvSpPr>
           <p:spPr>
             <a:xfrm>
-              <a:off x="2334886" y="4251517"/>
+              <a:off x="2334886" y="4251511"/>
               <a:ext cx="745236" cy="191932"/>
             </a:xfrm>
             <a:custGeom>
@@ -62993,7 +62874,7 @@
           </p:nvSpPr>
           <p:spPr>
             <a:xfrm>
-              <a:off x="2380606" y="4297237"/>
+              <a:off x="2380606" y="4297231"/>
               <a:ext cx="653796" cy="100492"/>
             </a:xfrm>
             <a:prstGeom prst="rect">
@@ -63040,14 +62921,14 @@
           <p:spPr>
             <a:xfrm>
               <a:off x="3114115" y="4572330"/>
-              <a:ext cx="114587" cy="656102"/>
+              <a:ext cx="114586" cy="656103"/>
             </a:xfrm>
             <a:custGeom>
               <a:avLst/>
               <a:pathLst>
-                <a:path w="114587" h="656102">
+                <a:path w="114586" h="656103">
                   <a:moveTo>
-                    <a:pt x="114587" y="656102"/>
+                    <a:pt x="114586" y="656103"/>
                   </a:moveTo>
                   <a:lnTo>
                     <a:pt x="0" y="0"/>
@@ -63079,7 +62960,7 @@
           </p:nvSpPr>
           <p:spPr>
             <a:xfrm>
-              <a:off x="3228702" y="5145554"/>
+              <a:off x="3228702" y="5145555"/>
               <a:ext cx="535106" cy="191932"/>
             </a:xfrm>
             <a:custGeom>
@@ -63174,7 +63055,7 @@
                     <a:pt x="17704" y="1782"/>
                   </a:lnTo>
                   <a:lnTo>
-                    <a:pt x="13716" y="3675"/>
+                    <a:pt x="13715" y="3675"/>
                   </a:lnTo>
                   <a:lnTo>
                     <a:pt x="10082" y="6183"/>
@@ -63222,7 +63103,7 @@
                     <a:pt x="10082" y="185749"/>
                   </a:lnTo>
                   <a:lnTo>
-                    <a:pt x="13716" y="188257"/>
+                    <a:pt x="13715" y="188257"/>
                   </a:lnTo>
                   <a:lnTo>
                     <a:pt x="17704" y="190149"/>
@@ -63266,7 +63147,7 @@
           </p:nvSpPr>
           <p:spPr>
             <a:xfrm>
-              <a:off x="3274422" y="5191274"/>
+              <a:off x="3274422" y="5191275"/>
               <a:ext cx="443666" cy="100492"/>
             </a:xfrm>
             <a:prstGeom prst="rect">

</xml_diff>